<commit_message>
update GMC architecture and correct introduction values
</commit_message>
<xml_diff>
--- a/2027_ICASSP/figures/GMC-Link Architecture.pptx
+++ b/2027_ICASSP/figures/GMC-Link Architecture.pptx
@@ -3813,10 +3813,10 @@
         </p:nvGrpSpPr>
         <p:grpSpPr>
           <a:xfrm>
-            <a:off x="1196903" y="3758143"/>
-            <a:ext cx="1565619" cy="494433"/>
-            <a:chOff x="0" y="-9525"/>
-            <a:chExt cx="2087492" cy="659243"/>
+            <a:off x="1241083" y="3736962"/>
+            <a:ext cx="1607236" cy="494432"/>
+            <a:chOff x="-55489" y="-9522"/>
+            <a:chExt cx="2142981" cy="659242"/>
           </a:xfrm>
         </p:grpSpPr>
         <p:sp>
@@ -3879,7 +3879,7 @@
           </p:nvSpPr>
           <p:spPr>
             <a:xfrm>
-              <a:off x="0" y="-9525"/>
+              <a:off x="-55489" y="-9522"/>
               <a:ext cx="2087489" cy="659242"/>
             </a:xfrm>
             <a:prstGeom prst="rect">
@@ -3905,7 +3905,7 @@
                   <a:cs typeface="Times New Roman"/>
                   <a:sym typeface="Times New Roman"/>
                 </a:rPr>
-                <a:t>13D Motion Vector</a:t>
+                <a:t>12D Motion Vector</a:t>
               </a:r>
             </a:p>
           </p:txBody>
@@ -4025,7 +4025,7 @@
         </p:nvGrpSpPr>
         <p:grpSpPr>
           <a:xfrm>
-            <a:off x="1126154" y="3159494"/>
+            <a:off x="1209154" y="2886082"/>
             <a:ext cx="10817746" cy="3095618"/>
             <a:chOff x="-611068" y="-1188393"/>
             <a:chExt cx="7236413" cy="3614293"/>

</xml_diff>